<commit_message>
Add Further Resources slide to main deck; update mantra in PPTX decks
- Add a two-column 'Where to go next' resources slide to
  decks/02-workshop-99p.pptx (before the closing slide), matching the
  deck's type system (Aptos, accent C14E3F) with annotated, hyperlinked
  entries; renumber pages accordingly
- Update the closing mantra to 'Start small. Write it down. Verify
  before you trust.' in both PPTX decks

Co-Authored-By: Claude Opus 4.8 <noreply@anthropic.com>
</commit_message>
<xml_diff>
--- a/decks/02-workshop-99p.pptx
+++ b/decks/02-workshop-99p.pptx
@@ -31,6 +31,7 @@
     <p:sldId id="273" r:id="rId28"/>
     <p:sldId id="274" r:id="rId29"/>
     <p:sldId id="275" r:id="rId30"/>
+    <p:sldId id="277" r:id="rId32"/>
     <p:sldId id="276" r:id="rId31"/>
   </p:sldIdLst>
   <p:sldSz cx="12192000" cy="6858000"/>
@@ -15701,7 +15702,7 @@
                 </a:solidFill>
                 <a:latin typeface="Aptos"/>
               </a:rPr>
-              <a:t>Use the lowest rung that works.</a:t>
+              <a:t>Start small.</a:t>
             </a:r>
           </a:p>
           <a:p>
@@ -15724,7 +15725,7 @@
                 </a:solidFill>
                 <a:latin typeface="Aptos"/>
               </a:rPr>
-              <a:t>Document everything.</a:t>
+              <a:t>Write it down.</a:t>
             </a:r>
           </a:p>
           <a:p>
@@ -15747,7 +15748,7 @@
                 </a:solidFill>
                 <a:latin typeface="Aptos"/>
               </a:rPr>
-              <a:t>Trust nothing you haven't checked.</a:t>
+              <a:t>Verify before you trust.</a:t>
             </a:r>
           </a:p>
         </p:txBody>
@@ -15777,6 +15778,749 @@
             <a:pPr algn="r"/>
             <a:r>
               <a:rPr sz="1100">
+                <a:solidFill>
+                  <a:srgbClr val="666666"/>
+                </a:solidFill>
+                <a:latin typeface="Aptos"/>
+              </a:rPr>
+              <a:t>21</a:t>
+            </a:r>
+          </a:p>
+        </p:txBody>
+      </p:sp>
+    </p:spTree>
+  </p:cSld>
+  <p:clrMapOvr>
+    <a:masterClrMapping/>
+  </p:clrMapOvr>
+</p:sld>
+</file>
+
+<file path=ppt/slides/slide22.xml><?xml version="1.0" encoding="utf-8"?>
+<p:sld xmlns:a="http://schemas.openxmlformats.org/drawingml/2006/main" xmlns:p="http://schemas.openxmlformats.org/presentationml/2006/main" xmlns:r="http://schemas.openxmlformats.org/officeDocument/2006/relationships">
+  <p:cSld>
+    <p:spTree>
+      <p:nvGrpSpPr>
+        <p:cNvPr id="1" name=""/>
+        <p:cNvGrpSpPr/>
+        <p:nvPr/>
+      </p:nvGrpSpPr>
+      <p:grpSpPr/>
+      <p:sp>
+        <p:nvSpPr>
+          <p:cNvPr id="2" name="TextBox 1"/>
+          <p:cNvSpPr txBox="1"/>
+          <p:nvPr/>
+        </p:nvSpPr>
+        <p:spPr>
+          <a:xfrm>
+            <a:off x="822960" y="457200"/>
+            <a:ext cx="10543032" cy="365760"/>
+          </a:xfrm>
+          <a:prstGeom prst="rect">
+            <a:avLst/>
+          </a:prstGeom>
+          <a:noFill/>
+        </p:spPr>
+        <p:txBody>
+          <a:bodyPr wrap="square" lIns="0" rIns="0" tIns="0" bIns="0">
+            <a:spAutoFit/>
+          </a:bodyPr>
+          <a:lstStyle/>
+          <a:p>
+            <a:pPr algn="l">
+              <a:lnSpc>
+                <a:spcPct val="118000"/>
+              </a:lnSpc>
+              <a:spcBef>
+                <a:spcPts val="0"/>
+              </a:spcBef>
+              <a:spcAft>
+                <a:spcPts val="600"/>
+              </a:spcAft>
+            </a:pPr>
+            <a:r>
+              <a:rPr sz="1200" b="1">
+                <a:solidFill>
+                  <a:srgbClr val="C14E3F"/>
+                </a:solidFill>
+                <a:latin typeface="Aptos"/>
+              </a:rPr>
+              <a:t>KEEP GOING · GO DEEPER</a:t>
+            </a:r>
+          </a:p>
+        </p:txBody>
+      </p:sp>
+      <p:sp>
+        <p:nvSpPr>
+          <p:cNvPr id="3" name="TextBox 2"/>
+          <p:cNvSpPr txBox="1"/>
+          <p:nvPr/>
+        </p:nvSpPr>
+        <p:spPr>
+          <a:xfrm>
+            <a:off x="822960" y="841248"/>
+            <a:ext cx="10543032" cy="914400"/>
+          </a:xfrm>
+          <a:prstGeom prst="rect">
+            <a:avLst/>
+          </a:prstGeom>
+          <a:noFill/>
+        </p:spPr>
+        <p:txBody>
+          <a:bodyPr wrap="square" lIns="0" rIns="0" tIns="0" bIns="0">
+            <a:spAutoFit/>
+          </a:bodyPr>
+          <a:lstStyle/>
+          <a:p>
+            <a:pPr algn="l">
+              <a:lnSpc>
+                <a:spcPct val="108000"/>
+              </a:lnSpc>
+              <a:spcBef>
+                <a:spcPts val="0"/>
+              </a:spcBef>
+              <a:spcAft>
+                <a:spcPts val="600"/>
+              </a:spcAft>
+            </a:pPr>
+            <a:r>
+              <a:rPr sz="3000" b="1">
+                <a:solidFill>
+                  <a:srgbClr val="1A1A1A"/>
+                </a:solidFill>
+                <a:latin typeface="Aptos"/>
+              </a:rPr>
+              <a:t>Where to go next.</a:t>
+            </a:r>
+          </a:p>
+        </p:txBody>
+      </p:sp>
+      <p:sp>
+        <p:nvSpPr>
+          <p:cNvPr id="4" name="TextBox 3"/>
+          <p:cNvSpPr txBox="1"/>
+          <p:nvPr/>
+        </p:nvSpPr>
+        <p:spPr>
+          <a:xfrm>
+            <a:off x="822960" y="1755648"/>
+            <a:ext cx="10543032" cy="457200"/>
+          </a:xfrm>
+          <a:prstGeom prst="rect">
+            <a:avLst/>
+          </a:prstGeom>
+          <a:noFill/>
+        </p:spPr>
+        <p:txBody>
+          <a:bodyPr wrap="square" lIns="0" rIns="0" tIns="0" bIns="0">
+            <a:spAutoFit/>
+          </a:bodyPr>
+          <a:lstStyle/>
+          <a:p>
+            <a:pPr algn="l">
+              <a:lnSpc>
+                <a:spcPct val="120000"/>
+              </a:lnSpc>
+              <a:spcBef>
+                <a:spcPts val="0"/>
+              </a:spcBef>
+              <a:spcAft>
+                <a:spcPts val="0"/>
+              </a:spcAft>
+            </a:pPr>
+            <a:r>
+              <a:rPr sz="1600" b="0">
+                <a:solidFill>
+                  <a:srgbClr val="1A1A1A"/>
+                </a:solidFill>
+                <a:latin typeface="Aptos"/>
+              </a:rPr>
+              <a:t>The ideas behind this workshop, in the words of the people who shaped them.</a:t>
+            </a:r>
+          </a:p>
+        </p:txBody>
+      </p:sp>
+      <p:sp>
+        <p:nvSpPr>
+          <p:cNvPr id="5" name="TextBox 4"/>
+          <p:cNvSpPr txBox="1"/>
+          <p:nvPr/>
+        </p:nvSpPr>
+        <p:spPr>
+          <a:xfrm>
+            <a:off x="822960" y="2331720"/>
+            <a:ext cx="5029200" cy="3840480"/>
+          </a:xfrm>
+          <a:prstGeom prst="rect">
+            <a:avLst/>
+          </a:prstGeom>
+          <a:noFill/>
+        </p:spPr>
+        <p:txBody>
+          <a:bodyPr wrap="square" lIns="0" rIns="0" tIns="0" bIns="0">
+            <a:spAutoFit/>
+          </a:bodyPr>
+          <a:lstStyle/>
+          <a:p>
+            <a:pPr algn="l">
+              <a:lnSpc>
+                <a:spcPct val="105000"/>
+              </a:lnSpc>
+              <a:spcBef>
+                <a:spcPts val="0"/>
+              </a:spcBef>
+              <a:spcAft>
+                <a:spcPts val="400"/>
+              </a:spcAft>
+            </a:pPr>
+            <a:r>
+              <a:rPr sz="1300" b="1">
+                <a:solidFill>
+                  <a:srgbClr val="C14E3F"/>
+                </a:solidFill>
+                <a:latin typeface="Aptos"/>
+              </a:rPr>
+              <a:t>THE PATTERN ITSELF</a:t>
+            </a:r>
+          </a:p>
+          <a:p>
+            <a:pPr algn="l">
+              <a:lnSpc>
+                <a:spcPct val="108000"/>
+              </a:lnSpc>
+              <a:spcBef>
+                <a:spcPts val="0"/>
+              </a:spcBef>
+              <a:spcAft>
+                <a:spcPts val="200"/>
+              </a:spcAft>
+            </a:pPr>
+            <a:r>
+              <a:rPr sz="1200" b="1" u="sng">
+                <a:solidFill>
+                  <a:srgbClr val="1A1A1A"/>
+                </a:solidFill>
+                <a:latin typeface="Aptos"/>
+                <a:hlinkClick r:id="rId2"/>
+              </a:rPr>
+              <a:t>Karpathy — “LLM Knowledge Bases” (tweet)</a:t>
+            </a:r>
+          </a:p>
+          <a:p>
+            <a:pPr algn="l">
+              <a:lnSpc>
+                <a:spcPct val="112000"/>
+              </a:lnSpc>
+              <a:spcBef>
+                <a:spcPts val="100"/>
+              </a:spcBef>
+              <a:spcAft>
+                <a:spcPts val="900"/>
+              </a:spcAft>
+            </a:pPr>
+            <a:r>
+              <a:rPr sz="1000" b="0">
+                <a:solidFill>
+                  <a:srgbClr val="666666"/>
+                </a:solidFill>
+                <a:latin typeface="Aptos"/>
+              </a:rPr>
+              <a:t>The post that started it: grow a knowledge base, don’t just generate code.</a:t>
+            </a:r>
+          </a:p>
+          <a:p>
+            <a:pPr algn="l">
+              <a:lnSpc>
+                <a:spcPct val="108000"/>
+              </a:lnSpc>
+              <a:spcBef>
+                <a:spcPts val="0"/>
+              </a:spcBef>
+              <a:spcAft>
+                <a:spcPts val="200"/>
+              </a:spcAft>
+            </a:pPr>
+            <a:r>
+              <a:rPr sz="1200" b="1" u="sng">
+                <a:solidFill>
+                  <a:srgbClr val="1A1A1A"/>
+                </a:solidFill>
+                <a:latin typeface="Aptos"/>
+                <a:hlinkClick r:id="rId3"/>
+              </a:rPr>
+              <a:t>Karpathy — llm-wiki (gist)</a:t>
+            </a:r>
+          </a:p>
+          <a:p>
+            <a:pPr algn="l">
+              <a:lnSpc>
+                <a:spcPct val="112000"/>
+              </a:lnSpc>
+              <a:spcBef>
+                <a:spcPts val="100"/>
+              </a:spcBef>
+              <a:spcAft>
+                <a:spcPts val="900"/>
+              </a:spcAft>
+            </a:pPr>
+            <a:r>
+              <a:rPr sz="1000" b="0">
+                <a:solidFill>
+                  <a:srgbClr val="666666"/>
+                </a:solidFill>
+                <a:latin typeface="Aptos"/>
+              </a:rPr>
+              <a:t>The blueprint behind sources/, wiki/, and AGENTS.md.</a:t>
+            </a:r>
+          </a:p>
+          <a:p>
+            <a:pPr algn="l">
+              <a:lnSpc>
+                <a:spcPct val="105000"/>
+              </a:lnSpc>
+              <a:spcBef>
+                <a:spcPts val="1300"/>
+              </a:spcBef>
+              <a:spcAft>
+                <a:spcPts val="400"/>
+              </a:spcAft>
+            </a:pPr>
+            <a:r>
+              <a:rPr sz="1300" b="1">
+                <a:solidFill>
+                  <a:srgbClr val="C14E3F"/>
+                </a:solidFill>
+                <a:latin typeface="Aptos"/>
+              </a:rPr>
+              <a:t>READ</a:t>
+            </a:r>
+          </a:p>
+          <a:p>
+            <a:pPr algn="l">
+              <a:lnSpc>
+                <a:spcPct val="108000"/>
+              </a:lnSpc>
+              <a:spcBef>
+                <a:spcPts val="0"/>
+              </a:spcBef>
+              <a:spcAft>
+                <a:spcPts val="200"/>
+              </a:spcAft>
+            </a:pPr>
+            <a:r>
+              <a:rPr sz="1200" b="1" u="sng">
+                <a:solidFill>
+                  <a:srgbClr val="1A1A1A"/>
+                </a:solidFill>
+                <a:latin typeface="Aptos"/>
+                <a:hlinkClick r:id="rId4"/>
+              </a:rPr>
+              <a:t>Hamel Husain &amp; Shreya Shankar — Evals FAQ</a:t>
+            </a:r>
+          </a:p>
+          <a:p>
+            <a:pPr algn="l">
+              <a:lnSpc>
+                <a:spcPct val="112000"/>
+              </a:lnSpc>
+              <a:spcBef>
+                <a:spcPts val="100"/>
+              </a:spcBef>
+              <a:spcAft>
+                <a:spcPts val="900"/>
+              </a:spcAft>
+            </a:pPr>
+            <a:r>
+              <a:rPr sz="1000" b="0">
+                <a:solidFill>
+                  <a:srgbClr val="666666"/>
+                </a:solidFill>
+                <a:latin typeface="Aptos"/>
+              </a:rPr>
+              <a:t>Error analysis and pass/fail — the backbone of Module 04.</a:t>
+            </a:r>
+          </a:p>
+          <a:p>
+            <a:pPr algn="l">
+              <a:lnSpc>
+                <a:spcPct val="108000"/>
+              </a:lnSpc>
+              <a:spcBef>
+                <a:spcPts val="0"/>
+              </a:spcBef>
+              <a:spcAft>
+                <a:spcPts val="200"/>
+              </a:spcAft>
+            </a:pPr>
+            <a:r>
+              <a:rPr sz="1200" b="1" u="sng">
+                <a:solidFill>
+                  <a:srgbClr val="1A1A1A"/>
+                </a:solidFill>
+                <a:latin typeface="Aptos"/>
+                <a:hlinkClick r:id="rId5"/>
+              </a:rPr>
+              <a:t>Ryan Lingo — “What Do We Mean by Learning?”</a:t>
+            </a:r>
+          </a:p>
+          <a:p>
+            <a:pPr algn="l">
+              <a:lnSpc>
+                <a:spcPct val="112000"/>
+              </a:lnSpc>
+              <a:spcBef>
+                <a:spcPts val="100"/>
+              </a:spcBef>
+              <a:spcAft>
+                <a:spcPts val="900"/>
+              </a:spcAft>
+            </a:pPr>
+            <a:r>
+              <a:rPr sz="1000" b="0">
+                <a:solidFill>
+                  <a:srgbClr val="666666"/>
+                </a:solidFill>
+                <a:latin typeface="Aptos"/>
+              </a:rPr>
+              <a:t>Eight kinds of learning — names what your learning log captures.</a:t>
+            </a:r>
+          </a:p>
+          <a:p>
+            <a:pPr algn="l">
+              <a:lnSpc>
+                <a:spcPct val="108000"/>
+              </a:lnSpc>
+              <a:spcBef>
+                <a:spcPts val="0"/>
+              </a:spcBef>
+              <a:spcAft>
+                <a:spcPts val="200"/>
+              </a:spcAft>
+            </a:pPr>
+            <a:r>
+              <a:rPr sz="1200" b="1" u="sng">
+                <a:solidFill>
+                  <a:srgbClr val="1A1A1A"/>
+                </a:solidFill>
+                <a:latin typeface="Aptos"/>
+                <a:hlinkClick r:id="rId6"/>
+              </a:rPr>
+              <a:t>a16z / Steven Sinofsky — on AI inside firms</a:t>
+            </a:r>
+          </a:p>
+          <a:p>
+            <a:pPr algn="l">
+              <a:lnSpc>
+                <a:spcPct val="112000"/>
+              </a:lnSpc>
+              <a:spcBef>
+                <a:spcPts val="100"/>
+              </a:spcBef>
+              <a:spcAft>
+                <a:spcPts val="900"/>
+              </a:spcAft>
+            </a:pPr>
+            <a:r>
+              <a:rPr sz="1000" b="0">
+                <a:solidFill>
+                  <a:srgbClr val="666666"/>
+                </a:solidFill>
+                <a:latin typeface="Aptos"/>
+              </a:rPr>
+              <a:t>Why making your process explicit is the hard part.</a:t>
+            </a:r>
+          </a:p>
+        </p:txBody>
+      </p:sp>
+      <p:sp>
+        <p:nvSpPr>
+          <p:cNvPr id="6" name="TextBox 5"/>
+          <p:cNvSpPr txBox="1"/>
+          <p:nvPr/>
+        </p:nvSpPr>
+        <p:spPr>
+          <a:xfrm>
+            <a:off x="6309360" y="2331720"/>
+            <a:ext cx="4937760" cy="3840480"/>
+          </a:xfrm>
+          <a:prstGeom prst="rect">
+            <a:avLst/>
+          </a:prstGeom>
+          <a:noFill/>
+        </p:spPr>
+        <p:txBody>
+          <a:bodyPr wrap="square" lIns="0" rIns="0" tIns="0" bIns="0">
+            <a:spAutoFit/>
+          </a:bodyPr>
+          <a:lstStyle/>
+          <a:p>
+            <a:pPr algn="l">
+              <a:lnSpc>
+                <a:spcPct val="105000"/>
+              </a:lnSpc>
+              <a:spcBef>
+                <a:spcPts val="0"/>
+              </a:spcBef>
+              <a:spcAft>
+                <a:spcPts val="400"/>
+              </a:spcAft>
+            </a:pPr>
+            <a:r>
+              <a:rPr sz="1300" b="1">
+                <a:solidFill>
+                  <a:srgbClr val="C14E3F"/>
+                </a:solidFill>
+                <a:latin typeface="Aptos"/>
+              </a:rPr>
+              <a:t>WATCH</a:t>
+            </a:r>
+          </a:p>
+          <a:p>
+            <a:pPr algn="l">
+              <a:lnSpc>
+                <a:spcPct val="108000"/>
+              </a:lnSpc>
+              <a:spcBef>
+                <a:spcPts val="0"/>
+              </a:spcBef>
+              <a:spcAft>
+                <a:spcPts val="200"/>
+              </a:spcAft>
+            </a:pPr>
+            <a:r>
+              <a:rPr sz="1200" b="1" u="sng">
+                <a:solidFill>
+                  <a:srgbClr val="1A1A1A"/>
+                </a:solidFill>
+                <a:latin typeface="Aptos"/>
+                <a:hlinkClick r:id="rId7"/>
+              </a:rPr>
+              <a:t>François Chollet — It’s Not About Scale, It’s About Abstraction</a:t>
+            </a:r>
+          </a:p>
+          <a:p>
+            <a:pPr algn="l">
+              <a:lnSpc>
+                <a:spcPct val="112000"/>
+              </a:lnSpc>
+              <a:spcBef>
+                <a:spcPts val="100"/>
+              </a:spcBef>
+              <a:spcAft>
+                <a:spcPts val="900"/>
+              </a:spcAft>
+            </a:pPr>
+            <a:r>
+              <a:rPr sz="1000" b="0">
+                <a:solidFill>
+                  <a:srgbClr val="666666"/>
+                </a:solidFill>
+                <a:latin typeface="Aptos"/>
+              </a:rPr>
+              <a:t>Intelligence is abstraction, not memorization — stay the thinker in the loop.</a:t>
+            </a:r>
+          </a:p>
+          <a:p>
+            <a:pPr algn="l">
+              <a:lnSpc>
+                <a:spcPct val="108000"/>
+              </a:lnSpc>
+              <a:spcBef>
+                <a:spcPts val="0"/>
+              </a:spcBef>
+              <a:spcAft>
+                <a:spcPts val="200"/>
+              </a:spcAft>
+            </a:pPr>
+            <a:r>
+              <a:rPr sz="1200" b="1" u="sng">
+                <a:solidFill>
+                  <a:srgbClr val="1A1A1A"/>
+                </a:solidFill>
+                <a:latin typeface="Aptos"/>
+                <a:hlinkClick r:id="rId8"/>
+              </a:rPr>
+              <a:t>Kenneth Stanley — Why Greatness Cannot Be Planned</a:t>
+            </a:r>
+          </a:p>
+          <a:p>
+            <a:pPr algn="l">
+              <a:lnSpc>
+                <a:spcPct val="112000"/>
+              </a:lnSpc>
+              <a:spcBef>
+                <a:spcPts val="100"/>
+              </a:spcBef>
+              <a:spcAft>
+                <a:spcPts val="900"/>
+              </a:spcAft>
+            </a:pPr>
+            <a:r>
+              <a:rPr sz="1000" b="0">
+                <a:solidFill>
+                  <a:srgbClr val="666666"/>
+                </a:solidFill>
+                <a:latin typeface="Aptos"/>
+              </a:rPr>
+              <a:t>Open-ended exploration compounds, like a wiki you keep feeding.</a:t>
+            </a:r>
+          </a:p>
+          <a:p>
+            <a:pPr algn="l">
+              <a:lnSpc>
+                <a:spcPct val="105000"/>
+              </a:lnSpc>
+              <a:spcBef>
+                <a:spcPts val="1300"/>
+              </a:spcBef>
+              <a:spcAft>
+                <a:spcPts val="400"/>
+              </a:spcAft>
+            </a:pPr>
+            <a:r>
+              <a:rPr sz="1300" b="1">
+                <a:solidFill>
+                  <a:srgbClr val="C14E3F"/>
+                </a:solidFill>
+                <a:latin typeface="Aptos"/>
+              </a:rPr>
+              <a:t>BOOKS</a:t>
+            </a:r>
+          </a:p>
+          <a:p>
+            <a:pPr algn="l">
+              <a:lnSpc>
+                <a:spcPct val="108000"/>
+              </a:lnSpc>
+              <a:spcBef>
+                <a:spcPts val="0"/>
+              </a:spcBef>
+              <a:spcAft>
+                <a:spcPts val="200"/>
+              </a:spcAft>
+            </a:pPr>
+            <a:r>
+              <a:rPr sz="1200" b="1">
+                <a:solidFill>
+                  <a:srgbClr val="1A1A1A"/>
+                </a:solidFill>
+                <a:latin typeface="Aptos"/>
+              </a:rPr>
+              <a:t>Algorithms to Live By</a:t>
+            </a:r>
+            <a:r>
+              <a:rPr sz="1200" b="0">
+                <a:solidFill>
+                  <a:srgbClr val="1A1A1A"/>
+                </a:solidFill>
+                <a:latin typeface="Aptos"/>
+              </a:rPr>
+              <a:t>  — Christian &amp; Griffiths</a:t>
+            </a:r>
+          </a:p>
+          <a:p>
+            <a:pPr algn="l">
+              <a:lnSpc>
+                <a:spcPct val="112000"/>
+              </a:lnSpc>
+              <a:spcBef>
+                <a:spcPts val="100"/>
+              </a:spcBef>
+              <a:spcAft>
+                <a:spcPts val="900"/>
+              </a:spcAft>
+            </a:pPr>
+            <a:r>
+              <a:rPr sz="1000" b="0">
+                <a:solidFill>
+                  <a:srgbClr val="666666"/>
+                </a:solidFill>
+                <a:latin typeface="Aptos"/>
+              </a:rPr>
+              <a:t>When to stop, when to explore vs. exploit — “the lowest rung that works.”</a:t>
+            </a:r>
+          </a:p>
+          <a:p>
+            <a:pPr algn="l">
+              <a:lnSpc>
+                <a:spcPct val="108000"/>
+              </a:lnSpc>
+              <a:spcBef>
+                <a:spcPts val="0"/>
+              </a:spcBef>
+              <a:spcAft>
+                <a:spcPts val="200"/>
+              </a:spcAft>
+            </a:pPr>
+            <a:r>
+              <a:rPr sz="1200" b="1">
+                <a:solidFill>
+                  <a:srgbClr val="1A1A1A"/>
+                </a:solidFill>
+                <a:latin typeface="Aptos"/>
+              </a:rPr>
+              <a:t>The Model Thinker</a:t>
+            </a:r>
+            <a:r>
+              <a:rPr sz="1200" b="0">
+                <a:solidFill>
+                  <a:srgbClr val="1A1A1A"/>
+                </a:solidFill>
+                <a:latin typeface="Aptos"/>
+              </a:rPr>
+              <a:t>  — Scott E. Page</a:t>
+            </a:r>
+          </a:p>
+          <a:p>
+            <a:pPr algn="l">
+              <a:lnSpc>
+                <a:spcPct val="112000"/>
+              </a:lnSpc>
+              <a:spcBef>
+                <a:spcPts val="100"/>
+              </a:spcBef>
+              <a:spcAft>
+                <a:spcPts val="900"/>
+              </a:spcAft>
+            </a:pPr>
+            <a:r>
+              <a:rPr sz="1000" b="0">
+                <a:solidFill>
+                  <a:srgbClr val="666666"/>
+                </a:solidFill>
+                <a:latin typeface="Aptos"/>
+              </a:rPr>
+              <a:t>Reason in many models at once — the habit a linked wiki supports.</a:t>
+            </a:r>
+          </a:p>
+        </p:txBody>
+      </p:sp>
+      <p:sp>
+        <p:nvSpPr>
+          <p:cNvPr id="7" name="TextBox 6"/>
+          <p:cNvSpPr txBox="1"/>
+          <p:nvPr/>
+        </p:nvSpPr>
+        <p:spPr>
+          <a:xfrm>
+            <a:off x="10911535" y="6355080"/>
+            <a:ext cx="914400" cy="320040"/>
+          </a:xfrm>
+          <a:prstGeom prst="rect">
+            <a:avLst/>
+          </a:prstGeom>
+          <a:noFill/>
+        </p:spPr>
+        <p:txBody>
+          <a:bodyPr wrap="square" lIns="0" rIns="0" tIns="0" bIns="0">
+            <a:spAutoFit/>
+          </a:bodyPr>
+          <a:lstStyle/>
+          <a:p>
+            <a:pPr algn="r"/>
+            <a:r>
+              <a:rPr sz="1100" b="0">
                 <a:solidFill>
                   <a:srgbClr val="666666"/>
                 </a:solidFill>

</xml_diff>